<commit_message>
Put group 14 names from the class sheet on the cover and README.
Nguyễn Trí Toàn, Nguyễn Văn Thái, Đỗ Quốc Hoàng.
</commit_message>
<xml_diff>
--- a/slides/CS221-Vietnews-tom-tat.pptx
+++ b/slides/CS221-Vietnews-tom-tat.pptx
@@ -2994,7 +2994,7 @@
         </p:nvSpPr>
         <p:spPr>
           <a:xfrm>
-            <a:off x="640080" y="4160520"/>
+            <a:off x="640080" y="4069080"/>
             <a:ext cx="10058400" cy="640080"/>
           </a:xfrm>
           <a:prstGeom prst="rect">
@@ -3045,6 +3045,62 @@
       <p:sp>
         <p:nvSpPr>
           <p:cNvPr id="7" name="Text 5"/>
+          <p:cNvSpPr/>
+          <p:nvPr/>
+        </p:nvSpPr>
+        <p:spPr>
+          <a:xfrm>
+            <a:off x="640080" y="4846320"/>
+            <a:ext cx="10972800" cy="640080"/>
+          </a:xfrm>
+          <a:prstGeom prst="rect">
+            <a:avLst/>
+          </a:prstGeom>
+          <a:noFill/>
+          <a:ln/>
+        </p:spPr>
+        <p:txBody>
+          <a:bodyPr wrap="square" lIns="0" tIns="0" rIns="0" bIns="0" rtlCol="0" anchor="ctr"/>
+          <a:lstStyle/>
+          <a:p>
+            <a:pPr indent="0" marL="0">
+              <a:buNone/>
+            </a:pPr>
+            <a:r>
+              <a:rPr lang="en-US" sz="1400" dirty="0">
+                <a:solidFill>
+                  <a:srgbClr val="1A1A1A"/>
+                </a:solidFill>
+                <a:latin typeface="Calibri" pitchFamily="34" charset="0"/>
+                <a:ea typeface="Calibri" pitchFamily="34" charset="-122"/>
+                <a:cs typeface="Calibri" pitchFamily="34" charset="-120"/>
+              </a:rPr>
+              <a:t>Nhóm 14</a:t>
+            </a:r>
+            <a:endParaRPr lang="en-US" sz="1400" dirty="0"/>
+          </a:p>
+          <a:p>
+            <a:pPr indent="0" marL="0">
+              <a:buNone/>
+            </a:pPr>
+            <a:r>
+              <a:rPr lang="en-US" sz="1400" dirty="0">
+                <a:solidFill>
+                  <a:srgbClr val="1A1A1A"/>
+                </a:solidFill>
+                <a:latin typeface="Calibri" pitchFamily="34" charset="0"/>
+                <a:ea typeface="Calibri" pitchFamily="34" charset="-122"/>
+                <a:cs typeface="Calibri" pitchFamily="34" charset="-120"/>
+              </a:rPr>
+              <a:t>Nguyễn Trí Toàn  26410135    ·    Nguyễn Văn Thái  26410108    ·    Đỗ Quốc Hoàng  26410043</a:t>
+            </a:r>
+            <a:endParaRPr lang="en-US" sz="1400" dirty="0"/>
+          </a:p>
+        </p:txBody>
+      </p:sp>
+      <p:sp>
+        <p:nvSpPr>
+          <p:cNvPr id="8" name="Text 6"/>
           <p:cNvSpPr/>
           <p:nvPr/>
         </p:nvSpPr>

</xml_diff>

<commit_message>
docs: add group 14 member names to cover and README
</commit_message>
<xml_diff>
--- a/slides/CS221-Vietnews-tom-tat.pptx
+++ b/slides/CS221-Vietnews-tom-tat.pptx
@@ -2994,7 +2994,7 @@
         </p:nvSpPr>
         <p:spPr>
           <a:xfrm>
-            <a:off x="640080" y="4160520"/>
+            <a:off x="640080" y="4069080"/>
             <a:ext cx="10058400" cy="640080"/>
           </a:xfrm>
           <a:prstGeom prst="rect">
@@ -3045,6 +3045,62 @@
       <p:sp>
         <p:nvSpPr>
           <p:cNvPr id="7" name="Text 5"/>
+          <p:cNvSpPr/>
+          <p:nvPr/>
+        </p:nvSpPr>
+        <p:spPr>
+          <a:xfrm>
+            <a:off x="640080" y="4846320"/>
+            <a:ext cx="10972800" cy="640080"/>
+          </a:xfrm>
+          <a:prstGeom prst="rect">
+            <a:avLst/>
+          </a:prstGeom>
+          <a:noFill/>
+          <a:ln/>
+        </p:spPr>
+        <p:txBody>
+          <a:bodyPr wrap="square" lIns="0" tIns="0" rIns="0" bIns="0" rtlCol="0" anchor="ctr"/>
+          <a:lstStyle/>
+          <a:p>
+            <a:pPr indent="0" marL="0">
+              <a:buNone/>
+            </a:pPr>
+            <a:r>
+              <a:rPr lang="en-US" sz="1400" dirty="0">
+                <a:solidFill>
+                  <a:srgbClr val="1A1A1A"/>
+                </a:solidFill>
+                <a:latin typeface="Calibri" pitchFamily="34" charset="0"/>
+                <a:ea typeface="Calibri" pitchFamily="34" charset="-122"/>
+                <a:cs typeface="Calibri" pitchFamily="34" charset="-120"/>
+              </a:rPr>
+              <a:t>Nhóm 14</a:t>
+            </a:r>
+            <a:endParaRPr lang="en-US" sz="1400" dirty="0"/>
+          </a:p>
+          <a:p>
+            <a:pPr indent="0" marL="0">
+              <a:buNone/>
+            </a:pPr>
+            <a:r>
+              <a:rPr lang="en-US" sz="1400" dirty="0">
+                <a:solidFill>
+                  <a:srgbClr val="1A1A1A"/>
+                </a:solidFill>
+                <a:latin typeface="Calibri" pitchFamily="34" charset="0"/>
+                <a:ea typeface="Calibri" pitchFamily="34" charset="-122"/>
+                <a:cs typeface="Calibri" pitchFamily="34" charset="-120"/>
+              </a:rPr>
+              <a:t>Nguyễn Trí Toàn  26410135    ·    Nguyễn Văn Thái  26410108    ·    Đỗ Quốc Hoàng  26410043</a:t>
+            </a:r>
+            <a:endParaRPr lang="en-US" sz="1400" dirty="0"/>
+          </a:p>
+        </p:txBody>
+      </p:sp>
+      <p:sp>
+        <p:nvSpPr>
+          <p:cNvPr id="8" name="Text 6"/>
           <p:cNvSpPr/>
           <p:nvPr/>
         </p:nvSpPr>

</xml_diff>

<commit_message>
feat(eval): add locked ViT5 ROUGE on 500 articles
</commit_message>
<xml_diff>
--- a/slides/CS221-Vietnews-tom-tat.pptx
+++ b/slides/CS221-Vietnews-tom-tat.pptx
@@ -7018,7 +7018,7 @@
                 <a:ea typeface="Calibri" pitchFamily="34" charset="-122"/>
                 <a:cs typeface="Calibri" pitchFamily="34" charset="-120"/>
               </a:rPr>
-              <a:t>10c  N = 500  ·  EXTRACTIVE</a:t>
+              <a:t>10c  N = 500</a:t>
             </a:r>
             <a:endParaRPr lang="en-US" sz="1100" dirty="0"/>
           </a:p>
@@ -7119,7 +7119,7 @@
                 <a:ea typeface="Georgia" pitchFamily="34" charset="-122"/>
                 <a:cs typeface="Georgia" pitchFamily="34" charset="-120"/>
               </a:rPr>
-              <a:t>Lead-1 &gt; Lead-3. Oracle-3 ≈ 0,46 — còn câu tốt hơn 3 câu đầu.</a:t>
+              <a:t>ViT5 0,2784 &gt; Lead-1 0,2719. Oracle-3 ≈ 0,46.</a:t>
             </a:r>
             <a:endParaRPr lang="en-US" sz="2000" dirty="0"/>
           </a:p>
@@ -7153,7 +7153,7 @@
                 <a:gridCol w="1618488"/>
                 <a:gridCol w="1609344"/>
               </a:tblGrid>
-              <a:tr h="701040">
+              <a:tr h="600891">
                 <a:tc>
                   <a:txBody>
                     <a:bodyPr/>
@@ -7163,7 +7163,7 @@
                         <a:buNone/>
                       </a:pPr>
                       <a:r>
-                        <a:rPr lang="en-US" sz="1500" b="1" dirty="0">
+                        <a:rPr lang="en-US" sz="1400" b="1" dirty="0">
                           <a:solidFill>
                             <a:srgbClr val="EFE8D6"/>
                           </a:solidFill>
@@ -7173,7 +7173,7 @@
                         </a:rPr>
                         <a:t>Hệ</a:t>
                       </a:r>
-                      <a:endParaRPr lang="en-US" sz="1500" dirty="0">
+                      <a:endParaRPr lang="en-US" sz="1400" dirty="0">
                         <a:latin typeface="Calibri" charset="0"/>
                         <a:ea typeface="Calibri" charset="0"/>
                         <a:cs typeface="Calibri" charset="0"/>
@@ -7231,7 +7231,7 @@
                         <a:buNone/>
                       </a:pPr>
                       <a:r>
-                        <a:rPr lang="en-US" sz="1500" b="1" dirty="0">
+                        <a:rPr lang="en-US" sz="1400" b="1" dirty="0">
                           <a:solidFill>
                             <a:srgbClr val="EFE8D6"/>
                           </a:solidFill>
@@ -7241,7 +7241,7 @@
                         </a:rPr>
                         <a:t>ROUGE-1</a:t>
                       </a:r>
-                      <a:endParaRPr lang="en-US" sz="1500" dirty="0">
+                      <a:endParaRPr lang="en-US" sz="1400" dirty="0">
                         <a:latin typeface="Calibri" charset="0"/>
                         <a:ea typeface="Calibri" charset="0"/>
                         <a:cs typeface="Calibri" charset="0"/>
@@ -7299,7 +7299,7 @@
                         <a:buNone/>
                       </a:pPr>
                       <a:r>
-                        <a:rPr lang="en-US" sz="1500" b="1" dirty="0">
+                        <a:rPr lang="en-US" sz="1400" b="1" dirty="0">
                           <a:solidFill>
                             <a:srgbClr val="EFE8D6"/>
                           </a:solidFill>
@@ -7309,7 +7309,7 @@
                         </a:rPr>
                         <a:t>ROUGE-2</a:t>
                       </a:r>
-                      <a:endParaRPr lang="en-US" sz="1500" dirty="0">
+                      <a:endParaRPr lang="en-US" sz="1400" dirty="0">
                         <a:latin typeface="Calibri" charset="0"/>
                         <a:ea typeface="Calibri" charset="0"/>
                         <a:cs typeface="Calibri" charset="0"/>
@@ -7367,7 +7367,7 @@
                         <a:buNone/>
                       </a:pPr>
                       <a:r>
-                        <a:rPr lang="en-US" sz="1500" b="1" dirty="0">
+                        <a:rPr lang="en-US" sz="1400" b="1" dirty="0">
                           <a:solidFill>
                             <a:srgbClr val="EFE8D6"/>
                           </a:solidFill>
@@ -7377,7 +7377,7 @@
                         </a:rPr>
                         <a:t>ROUGE-L</a:t>
                       </a:r>
-                      <a:endParaRPr lang="en-US" sz="1500" dirty="0">
+                      <a:endParaRPr lang="en-US" sz="1400" dirty="0">
                         <a:latin typeface="Calibri" charset="0"/>
                         <a:ea typeface="Calibri" charset="0"/>
                         <a:cs typeface="Calibri" charset="0"/>
@@ -7427,7 +7427,7 @@
                   </a:tcPr>
                 </a:tc>
               </a:tr>
-              <a:tr h="701040">
+              <a:tr h="600891">
                 <a:tc>
                   <a:txBody>
                     <a:bodyPr/>
@@ -7437,7 +7437,7 @@
                         <a:buNone/>
                       </a:pPr>
                       <a:r>
-                        <a:rPr lang="en-US" sz="1500" dirty="0">
+                        <a:rPr lang="en-US" sz="1400" dirty="0">
                           <a:solidFill>
                             <a:srgbClr val="2B2B2B"/>
                           </a:solidFill>
@@ -7447,7 +7447,7 @@
                         </a:rPr>
                         <a:t>Lead-1</a:t>
                       </a:r>
-                      <a:endParaRPr lang="en-US" sz="1500" dirty="0">
+                      <a:endParaRPr lang="en-US" sz="1400" dirty="0">
                         <a:latin typeface="Calibri" charset="0"/>
                         <a:ea typeface="Calibri" charset="0"/>
                         <a:cs typeface="Calibri" charset="0"/>
@@ -7502,7 +7502,7 @@
                         <a:buNone/>
                       </a:pPr>
                       <a:r>
-                        <a:rPr lang="en-US" sz="1500" dirty="0">
+                        <a:rPr lang="en-US" sz="1400" dirty="0">
                           <a:solidFill>
                             <a:srgbClr val="2B2B2B"/>
                           </a:solidFill>
@@ -7512,7 +7512,7 @@
                         </a:rPr>
                         <a:t>0.2719</a:t>
                       </a:r>
-                      <a:endParaRPr lang="en-US" sz="1500" dirty="0">
+                      <a:endParaRPr lang="en-US" sz="1400" dirty="0">
                         <a:latin typeface="Calibri" charset="0"/>
                         <a:ea typeface="Calibri" charset="0"/>
                         <a:cs typeface="Calibri" charset="0"/>
@@ -7567,7 +7567,7 @@
                         <a:buNone/>
                       </a:pPr>
                       <a:r>
-                        <a:rPr lang="en-US" sz="1500" dirty="0">
+                        <a:rPr lang="en-US" sz="1400" dirty="0">
                           <a:solidFill>
                             <a:srgbClr val="2B2B2B"/>
                           </a:solidFill>
@@ -7577,7 +7577,7 @@
                         </a:rPr>
                         <a:t>0.1305</a:t>
                       </a:r>
-                      <a:endParaRPr lang="en-US" sz="1500" dirty="0">
+                      <a:endParaRPr lang="en-US" sz="1400" dirty="0">
                         <a:latin typeface="Calibri" charset="0"/>
                         <a:ea typeface="Calibri" charset="0"/>
                         <a:cs typeface="Calibri" charset="0"/>
@@ -7632,7 +7632,7 @@
                         <a:buNone/>
                       </a:pPr>
                       <a:r>
-                        <a:rPr lang="en-US" sz="1500" dirty="0">
+                        <a:rPr lang="en-US" sz="1400" dirty="0">
                           <a:solidFill>
                             <a:srgbClr val="2B2B2B"/>
                           </a:solidFill>
@@ -7642,7 +7642,7 @@
                         </a:rPr>
                         <a:t>0.2092</a:t>
                       </a:r>
-                      <a:endParaRPr lang="en-US" sz="1500" dirty="0">
+                      <a:endParaRPr lang="en-US" sz="1400" dirty="0">
                         <a:latin typeface="Calibri" charset="0"/>
                         <a:ea typeface="Calibri" charset="0"/>
                         <a:cs typeface="Calibri" charset="0"/>
@@ -7689,7 +7689,7 @@
                   </a:tcPr>
                 </a:tc>
               </a:tr>
-              <a:tr h="701040">
+              <a:tr h="600891">
                 <a:tc>
                   <a:txBody>
                     <a:bodyPr/>
@@ -7699,7 +7699,7 @@
                         <a:buNone/>
                       </a:pPr>
                       <a:r>
-                        <a:rPr lang="en-US" sz="1500" dirty="0">
+                        <a:rPr lang="en-US" sz="1400" dirty="0">
                           <a:solidFill>
                             <a:srgbClr val="2B2B2B"/>
                           </a:solidFill>
@@ -7709,7 +7709,7 @@
                         </a:rPr>
                         <a:t>Lead-3</a:t>
                       </a:r>
-                      <a:endParaRPr lang="en-US" sz="1500" dirty="0">
+                      <a:endParaRPr lang="en-US" sz="1400" dirty="0">
                         <a:latin typeface="Calibri" charset="0"/>
                         <a:ea typeface="Calibri" charset="0"/>
                         <a:cs typeface="Calibri" charset="0"/>
@@ -7764,7 +7764,7 @@
                         <a:buNone/>
                       </a:pPr>
                       <a:r>
-                        <a:rPr lang="en-US" sz="1500" dirty="0">
+                        <a:rPr lang="en-US" sz="1400" dirty="0">
                           <a:solidFill>
                             <a:srgbClr val="2B2B2B"/>
                           </a:solidFill>
@@ -7774,7 +7774,7 @@
                         </a:rPr>
                         <a:t>0.2569</a:t>
                       </a:r>
-                      <a:endParaRPr lang="en-US" sz="1500" dirty="0">
+                      <a:endParaRPr lang="en-US" sz="1400" dirty="0">
                         <a:latin typeface="Calibri" charset="0"/>
                         <a:ea typeface="Calibri" charset="0"/>
                         <a:cs typeface="Calibri" charset="0"/>
@@ -7829,7 +7829,7 @@
                         <a:buNone/>
                       </a:pPr>
                       <a:r>
-                        <a:rPr lang="en-US" sz="1500" dirty="0">
+                        <a:rPr lang="en-US" sz="1400" dirty="0">
                           <a:solidFill>
                             <a:srgbClr val="2B2B2B"/>
                           </a:solidFill>
@@ -7839,7 +7839,7 @@
                         </a:rPr>
                         <a:t>0.1294</a:t>
                       </a:r>
-                      <a:endParaRPr lang="en-US" sz="1500" dirty="0">
+                      <a:endParaRPr lang="en-US" sz="1400" dirty="0">
                         <a:latin typeface="Calibri" charset="0"/>
                         <a:ea typeface="Calibri" charset="0"/>
                         <a:cs typeface="Calibri" charset="0"/>
@@ -7894,7 +7894,7 @@
                         <a:buNone/>
                       </a:pPr>
                       <a:r>
-                        <a:rPr lang="en-US" sz="1500" dirty="0">
+                        <a:rPr lang="en-US" sz="1400" dirty="0">
                           <a:solidFill>
                             <a:srgbClr val="2B2B2B"/>
                           </a:solidFill>
@@ -7904,7 +7904,7 @@
                         </a:rPr>
                         <a:t>0.1856</a:t>
                       </a:r>
-                      <a:endParaRPr lang="en-US" sz="1500" dirty="0">
+                      <a:endParaRPr lang="en-US" sz="1400" dirty="0">
                         <a:latin typeface="Calibri" charset="0"/>
                         <a:ea typeface="Calibri" charset="0"/>
                         <a:cs typeface="Calibri" charset="0"/>
@@ -7951,7 +7951,7 @@
                   </a:tcPr>
                 </a:tc>
               </a:tr>
-              <a:tr h="701040">
+              <a:tr h="600891">
                 <a:tc>
                   <a:txBody>
                     <a:bodyPr/>
@@ -7961,7 +7961,7 @@
                         <a:buNone/>
                       </a:pPr>
                       <a:r>
-                        <a:rPr lang="en-US" sz="1500" dirty="0">
+                        <a:rPr lang="en-US" sz="1400" dirty="0">
                           <a:solidFill>
                             <a:srgbClr val="2B2B2B"/>
                           </a:solidFill>
@@ -7971,7 +7971,7 @@
                         </a:rPr>
                         <a:t>Lead-5</a:t>
                       </a:r>
-                      <a:endParaRPr lang="en-US" sz="1500" dirty="0">
+                      <a:endParaRPr lang="en-US" sz="1400" dirty="0">
                         <a:latin typeface="Calibri" charset="0"/>
                         <a:ea typeface="Calibri" charset="0"/>
                         <a:cs typeface="Calibri" charset="0"/>
@@ -8026,7 +8026,7 @@
                         <a:buNone/>
                       </a:pPr>
                       <a:r>
-                        <a:rPr lang="en-US" sz="1500" dirty="0">
+                        <a:rPr lang="en-US" sz="1400" dirty="0">
                           <a:solidFill>
                             <a:srgbClr val="2B2B2B"/>
                           </a:solidFill>
@@ -8036,7 +8036,7 @@
                         </a:rPr>
                         <a:t>0.2256</a:t>
                       </a:r>
-                      <a:endParaRPr lang="en-US" sz="1500" dirty="0">
+                      <a:endParaRPr lang="en-US" sz="1400" dirty="0">
                         <a:latin typeface="Calibri" charset="0"/>
                         <a:ea typeface="Calibri" charset="0"/>
                         <a:cs typeface="Calibri" charset="0"/>
@@ -8091,7 +8091,7 @@
                         <a:buNone/>
                       </a:pPr>
                       <a:r>
-                        <a:rPr lang="en-US" sz="1500" dirty="0">
+                        <a:rPr lang="en-US" sz="1400" dirty="0">
                           <a:solidFill>
                             <a:srgbClr val="2B2B2B"/>
                           </a:solidFill>
@@ -8101,7 +8101,7 @@
                         </a:rPr>
                         <a:t>0.1199</a:t>
                       </a:r>
-                      <a:endParaRPr lang="en-US" sz="1500" dirty="0">
+                      <a:endParaRPr lang="en-US" sz="1400" dirty="0">
                         <a:latin typeface="Calibri" charset="0"/>
                         <a:ea typeface="Calibri" charset="0"/>
                         <a:cs typeface="Calibri" charset="0"/>
@@ -8156,7 +8156,7 @@
                         <a:buNone/>
                       </a:pPr>
                       <a:r>
-                        <a:rPr lang="en-US" sz="1500" dirty="0">
+                        <a:rPr lang="en-US" sz="1400" dirty="0">
                           <a:solidFill>
                             <a:srgbClr val="2B2B2B"/>
                           </a:solidFill>
@@ -8166,7 +8166,7 @@
                         </a:rPr>
                         <a:t>0.1624</a:t>
                       </a:r>
-                      <a:endParaRPr lang="en-US" sz="1500" dirty="0">
+                      <a:endParaRPr lang="en-US" sz="1400" dirty="0">
                         <a:latin typeface="Calibri" charset="0"/>
                         <a:ea typeface="Calibri" charset="0"/>
                         <a:cs typeface="Calibri" charset="0"/>
@@ -8213,7 +8213,7 @@
                   </a:tcPr>
                 </a:tc>
               </a:tr>
-              <a:tr h="701040">
+              <a:tr h="600891">
                 <a:tc>
                   <a:txBody>
                     <a:bodyPr/>
@@ -8223,7 +8223,7 @@
                         <a:buNone/>
                       </a:pPr>
                       <a:r>
-                        <a:rPr lang="en-US" sz="1500" dirty="0">
+                        <a:rPr lang="en-US" sz="1400" dirty="0">
                           <a:solidFill>
                             <a:srgbClr val="2B2B2B"/>
                           </a:solidFill>
@@ -8233,7 +8233,7 @@
                         </a:rPr>
                         <a:t>TextRank-3</a:t>
                       </a:r>
-                      <a:endParaRPr lang="en-US" sz="1500" dirty="0">
+                      <a:endParaRPr lang="en-US" sz="1400" dirty="0">
                         <a:latin typeface="Calibri" charset="0"/>
                         <a:ea typeface="Calibri" charset="0"/>
                         <a:cs typeface="Calibri" charset="0"/>
@@ -8288,7 +8288,7 @@
                         <a:buNone/>
                       </a:pPr>
                       <a:r>
-                        <a:rPr lang="en-US" sz="1500" dirty="0">
+                        <a:rPr lang="en-US" sz="1400" dirty="0">
                           <a:solidFill>
                             <a:srgbClr val="2B2B2B"/>
                           </a:solidFill>
@@ -8298,7 +8298,7 @@
                         </a:rPr>
                         <a:t>0.2499</a:t>
                       </a:r>
-                      <a:endParaRPr lang="en-US" sz="1500" dirty="0">
+                      <a:endParaRPr lang="en-US" sz="1400" dirty="0">
                         <a:latin typeface="Calibri" charset="0"/>
                         <a:ea typeface="Calibri" charset="0"/>
                         <a:cs typeface="Calibri" charset="0"/>
@@ -8353,7 +8353,7 @@
                         <a:buNone/>
                       </a:pPr>
                       <a:r>
-                        <a:rPr lang="en-US" sz="1500" dirty="0">
+                        <a:rPr lang="en-US" sz="1400" dirty="0">
                           <a:solidFill>
                             <a:srgbClr val="2B2B2B"/>
                           </a:solidFill>
@@ -8363,7 +8363,7 @@
                         </a:rPr>
                         <a:t>0.1198</a:t>
                       </a:r>
-                      <a:endParaRPr lang="en-US" sz="1500" dirty="0">
+                      <a:endParaRPr lang="en-US" sz="1400" dirty="0">
                         <a:latin typeface="Calibri" charset="0"/>
                         <a:ea typeface="Calibri" charset="0"/>
                         <a:cs typeface="Calibri" charset="0"/>
@@ -8418,7 +8418,7 @@
                         <a:buNone/>
                       </a:pPr>
                       <a:r>
-                        <a:rPr lang="en-US" sz="1500" dirty="0">
+                        <a:rPr lang="en-US" sz="1400" dirty="0">
                           <a:solidFill>
                             <a:srgbClr val="2B2B2B"/>
                           </a:solidFill>
@@ -8428,7 +8428,7 @@
                         </a:rPr>
                         <a:t>0.1815</a:t>
                       </a:r>
-                      <a:endParaRPr lang="en-US" sz="1500" dirty="0">
+                      <a:endParaRPr lang="en-US" sz="1400" dirty="0">
                         <a:latin typeface="Calibri" charset="0"/>
                         <a:ea typeface="Calibri" charset="0"/>
                         <a:cs typeface="Calibri" charset="0"/>
@@ -8475,7 +8475,7 @@
                   </a:tcPr>
                 </a:tc>
               </a:tr>
-              <a:tr h="701040">
+              <a:tr h="600891">
                 <a:tc>
                   <a:txBody>
                     <a:bodyPr/>
@@ -8485,7 +8485,281 @@
                         <a:buNone/>
                       </a:pPr>
                       <a:r>
-                        <a:rPr lang="en-US" sz="1500" b="1" dirty="0">
+                        <a:rPr lang="en-US" sz="1400" b="1" dirty="0">
+                          <a:solidFill>
+                            <a:srgbClr val="2B2B2B"/>
+                          </a:solidFill>
+                          <a:latin typeface="Calibri" pitchFamily="34" charset="0"/>
+                          <a:ea typeface="Calibri" pitchFamily="34" charset="-122"/>
+                          <a:cs typeface="Calibri" pitchFamily="34" charset="-120"/>
+                        </a:rPr>
+                        <a:t>ViT5</a:t>
+                      </a:r>
+                      <a:endParaRPr lang="en-US" sz="1400" dirty="0">
+                        <a:latin typeface="Calibri" charset="0"/>
+                        <a:ea typeface="Calibri" charset="0"/>
+                        <a:cs typeface="Calibri" charset="0"/>
+                      </a:endParaRPr>
+                    </a:p>
+                  </a:txBody>
+                  <a:tcPr marL="91440" marR="91440" marT="45720" marB="45720" anchor="ctr">
+                    <a:lnL w="6350" cap="flat" cmpd="sng" algn="ctr">
+                      <a:solidFill>
+                        <a:srgbClr val="C8C0AE"/>
+                      </a:solidFill>
+                      <a:prstDash val="solid"/>
+                      <a:round/>
+                      <a:headEnd type="none" w="med" len="med"/>
+                      <a:tailEnd type="none" w="med" len="med"/>
+                    </a:lnL>
+                    <a:lnR w="6350" cap="flat" cmpd="sng" algn="ctr">
+                      <a:solidFill>
+                        <a:srgbClr val="C8C0AE"/>
+                      </a:solidFill>
+                      <a:prstDash val="solid"/>
+                      <a:round/>
+                      <a:headEnd type="none" w="med" len="med"/>
+                      <a:tailEnd type="none" w="med" len="med"/>
+                    </a:lnR>
+                    <a:lnT w="6350" cap="flat" cmpd="sng" algn="ctr">
+                      <a:solidFill>
+                        <a:srgbClr val="C8C0AE"/>
+                      </a:solidFill>
+                      <a:prstDash val="solid"/>
+                      <a:round/>
+                      <a:headEnd type="none" w="med" len="med"/>
+                      <a:tailEnd type="none" w="med" len="med"/>
+                    </a:lnT>
+                    <a:lnB w="6350" cap="flat" cmpd="sng" algn="ctr">
+                      <a:solidFill>
+                        <a:srgbClr val="C8C0AE"/>
+                      </a:solidFill>
+                      <a:prstDash val="solid"/>
+                      <a:round/>
+                      <a:headEnd type="none" w="med" len="med"/>
+                      <a:tailEnd type="none" w="med" len="med"/>
+                    </a:lnB>
+                    <a:solidFill>
+                      <a:srgbClr val="F7F3E8"/>
+                    </a:solidFill>
+                  </a:tcPr>
+                </a:tc>
+                <a:tc>
+                  <a:txBody>
+                    <a:bodyPr/>
+                    <a:lstStyle/>
+                    <a:p>
+                      <a:pPr algn="ctr" indent="0" marL="0">
+                        <a:buNone/>
+                      </a:pPr>
+                      <a:r>
+                        <a:rPr lang="en-US" sz="1400" b="1" dirty="0">
+                          <a:solidFill>
+                            <a:srgbClr val="2B2B2B"/>
+                          </a:solidFill>
+                          <a:latin typeface="Calibri" pitchFamily="34" charset="0"/>
+                          <a:ea typeface="Calibri" pitchFamily="34" charset="-122"/>
+                          <a:cs typeface="Calibri" pitchFamily="34" charset="-120"/>
+                        </a:rPr>
+                        <a:t>0.2784</a:t>
+                      </a:r>
+                      <a:endParaRPr lang="en-US" sz="1400" dirty="0">
+                        <a:latin typeface="Calibri" charset="0"/>
+                        <a:ea typeface="Calibri" charset="0"/>
+                        <a:cs typeface="Calibri" charset="0"/>
+                      </a:endParaRPr>
+                    </a:p>
+                  </a:txBody>
+                  <a:tcPr marL="91440" marR="91440" marT="45720" marB="45720" anchor="ctr">
+                    <a:lnL w="6350" cap="flat" cmpd="sng" algn="ctr">
+                      <a:solidFill>
+                        <a:srgbClr val="C8C0AE"/>
+                      </a:solidFill>
+                      <a:prstDash val="solid"/>
+                      <a:round/>
+                      <a:headEnd type="none" w="med" len="med"/>
+                      <a:tailEnd type="none" w="med" len="med"/>
+                    </a:lnL>
+                    <a:lnR w="6350" cap="flat" cmpd="sng" algn="ctr">
+                      <a:solidFill>
+                        <a:srgbClr val="C8C0AE"/>
+                      </a:solidFill>
+                      <a:prstDash val="solid"/>
+                      <a:round/>
+                      <a:headEnd type="none" w="med" len="med"/>
+                      <a:tailEnd type="none" w="med" len="med"/>
+                    </a:lnR>
+                    <a:lnT w="6350" cap="flat" cmpd="sng" algn="ctr">
+                      <a:solidFill>
+                        <a:srgbClr val="C8C0AE"/>
+                      </a:solidFill>
+                      <a:prstDash val="solid"/>
+                      <a:round/>
+                      <a:headEnd type="none" w="med" len="med"/>
+                      <a:tailEnd type="none" w="med" len="med"/>
+                    </a:lnT>
+                    <a:lnB w="6350" cap="flat" cmpd="sng" algn="ctr">
+                      <a:solidFill>
+                        <a:srgbClr val="C8C0AE"/>
+                      </a:solidFill>
+                      <a:prstDash val="solid"/>
+                      <a:round/>
+                      <a:headEnd type="none" w="med" len="med"/>
+                      <a:tailEnd type="none" w="med" len="med"/>
+                    </a:lnB>
+                    <a:solidFill>
+                      <a:srgbClr val="F7F3E8"/>
+                    </a:solidFill>
+                  </a:tcPr>
+                </a:tc>
+                <a:tc>
+                  <a:txBody>
+                    <a:bodyPr/>
+                    <a:lstStyle/>
+                    <a:p>
+                      <a:pPr algn="ctr" indent="0" marL="0">
+                        <a:buNone/>
+                      </a:pPr>
+                      <a:r>
+                        <a:rPr lang="en-US" sz="1400" b="1" dirty="0">
+                          <a:solidFill>
+                            <a:srgbClr val="2B2B2B"/>
+                          </a:solidFill>
+                          <a:latin typeface="Calibri" pitchFamily="34" charset="0"/>
+                          <a:ea typeface="Calibri" pitchFamily="34" charset="-122"/>
+                          <a:cs typeface="Calibri" pitchFamily="34" charset="-120"/>
+                        </a:rPr>
+                        <a:t>0.1474</a:t>
+                      </a:r>
+                      <a:endParaRPr lang="en-US" sz="1400" dirty="0">
+                        <a:latin typeface="Calibri" charset="0"/>
+                        <a:ea typeface="Calibri" charset="0"/>
+                        <a:cs typeface="Calibri" charset="0"/>
+                      </a:endParaRPr>
+                    </a:p>
+                  </a:txBody>
+                  <a:tcPr marL="91440" marR="91440" marT="45720" marB="45720" anchor="ctr">
+                    <a:lnL w="6350" cap="flat" cmpd="sng" algn="ctr">
+                      <a:solidFill>
+                        <a:srgbClr val="C8C0AE"/>
+                      </a:solidFill>
+                      <a:prstDash val="solid"/>
+                      <a:round/>
+                      <a:headEnd type="none" w="med" len="med"/>
+                      <a:tailEnd type="none" w="med" len="med"/>
+                    </a:lnL>
+                    <a:lnR w="6350" cap="flat" cmpd="sng" algn="ctr">
+                      <a:solidFill>
+                        <a:srgbClr val="C8C0AE"/>
+                      </a:solidFill>
+                      <a:prstDash val="solid"/>
+                      <a:round/>
+                      <a:headEnd type="none" w="med" len="med"/>
+                      <a:tailEnd type="none" w="med" len="med"/>
+                    </a:lnR>
+                    <a:lnT w="6350" cap="flat" cmpd="sng" algn="ctr">
+                      <a:solidFill>
+                        <a:srgbClr val="C8C0AE"/>
+                      </a:solidFill>
+                      <a:prstDash val="solid"/>
+                      <a:round/>
+                      <a:headEnd type="none" w="med" len="med"/>
+                      <a:tailEnd type="none" w="med" len="med"/>
+                    </a:lnT>
+                    <a:lnB w="6350" cap="flat" cmpd="sng" algn="ctr">
+                      <a:solidFill>
+                        <a:srgbClr val="C8C0AE"/>
+                      </a:solidFill>
+                      <a:prstDash val="solid"/>
+                      <a:round/>
+                      <a:headEnd type="none" w="med" len="med"/>
+                      <a:tailEnd type="none" w="med" len="med"/>
+                    </a:lnB>
+                    <a:solidFill>
+                      <a:srgbClr val="F7F3E8"/>
+                    </a:solidFill>
+                  </a:tcPr>
+                </a:tc>
+                <a:tc>
+                  <a:txBody>
+                    <a:bodyPr/>
+                    <a:lstStyle/>
+                    <a:p>
+                      <a:pPr algn="ctr" indent="0" marL="0">
+                        <a:buNone/>
+                      </a:pPr>
+                      <a:r>
+                        <a:rPr lang="en-US" sz="1400" b="1" dirty="0">
+                          <a:solidFill>
+                            <a:srgbClr val="2B2B2B"/>
+                          </a:solidFill>
+                          <a:latin typeface="Calibri" pitchFamily="34" charset="0"/>
+                          <a:ea typeface="Calibri" pitchFamily="34" charset="-122"/>
+                          <a:cs typeface="Calibri" pitchFamily="34" charset="-120"/>
+                        </a:rPr>
+                        <a:t>0.2233</a:t>
+                      </a:r>
+                      <a:endParaRPr lang="en-US" sz="1400" dirty="0">
+                        <a:latin typeface="Calibri" charset="0"/>
+                        <a:ea typeface="Calibri" charset="0"/>
+                        <a:cs typeface="Calibri" charset="0"/>
+                      </a:endParaRPr>
+                    </a:p>
+                  </a:txBody>
+                  <a:tcPr marL="91440" marR="91440" marT="45720" marB="45720" anchor="ctr">
+                    <a:lnL w="6350" cap="flat" cmpd="sng" algn="ctr">
+                      <a:solidFill>
+                        <a:srgbClr val="C8C0AE"/>
+                      </a:solidFill>
+                      <a:prstDash val="solid"/>
+                      <a:round/>
+                      <a:headEnd type="none" w="med" len="med"/>
+                      <a:tailEnd type="none" w="med" len="med"/>
+                    </a:lnL>
+                    <a:lnR w="6350" cap="flat" cmpd="sng" algn="ctr">
+                      <a:solidFill>
+                        <a:srgbClr val="C8C0AE"/>
+                      </a:solidFill>
+                      <a:prstDash val="solid"/>
+                      <a:round/>
+                      <a:headEnd type="none" w="med" len="med"/>
+                      <a:tailEnd type="none" w="med" len="med"/>
+                    </a:lnR>
+                    <a:lnT w="6350" cap="flat" cmpd="sng" algn="ctr">
+                      <a:solidFill>
+                        <a:srgbClr val="C8C0AE"/>
+                      </a:solidFill>
+                      <a:prstDash val="solid"/>
+                      <a:round/>
+                      <a:headEnd type="none" w="med" len="med"/>
+                      <a:tailEnd type="none" w="med" len="med"/>
+                    </a:lnT>
+                    <a:lnB w="6350" cap="flat" cmpd="sng" algn="ctr">
+                      <a:solidFill>
+                        <a:srgbClr val="C8C0AE"/>
+                      </a:solidFill>
+                      <a:prstDash val="solid"/>
+                      <a:round/>
+                      <a:headEnd type="none" w="med" len="med"/>
+                      <a:tailEnd type="none" w="med" len="med"/>
+                    </a:lnB>
+                    <a:solidFill>
+                      <a:srgbClr val="F7F3E8"/>
+                    </a:solidFill>
+                  </a:tcPr>
+                </a:tc>
+              </a:tr>
+              <a:tr h="600891">
+                <a:tc>
+                  <a:txBody>
+                    <a:bodyPr/>
+                    <a:lstStyle/>
+                    <a:p>
+                      <a:pPr algn="ctr" indent="0" marL="0">
+                        <a:buNone/>
+                      </a:pPr>
+                      <a:r>
+                        <a:rPr lang="en-US" sz="1400" b="1" dirty="0">
                           <a:solidFill>
                             <a:srgbClr val="2B2B2B"/>
                           </a:solidFill>
@@ -8495,7 +8769,7 @@
                         </a:rPr>
                         <a:t>Oracle-3</a:t>
                       </a:r>
-                      <a:endParaRPr lang="en-US" sz="1500" dirty="0">
+                      <a:endParaRPr lang="en-US" sz="1400" dirty="0">
                         <a:latin typeface="Calibri" charset="0"/>
                         <a:ea typeface="Calibri" charset="0"/>
                         <a:cs typeface="Calibri" charset="0"/>
@@ -8553,7 +8827,7 @@
                         <a:buNone/>
                       </a:pPr>
                       <a:r>
-                        <a:rPr lang="en-US" sz="1500" b="1" dirty="0">
+                        <a:rPr lang="en-US" sz="1400" b="1" dirty="0">
                           <a:solidFill>
                             <a:srgbClr val="2B2B2B"/>
                           </a:solidFill>
@@ -8563,7 +8837,7 @@
                         </a:rPr>
                         <a:t>0.4646</a:t>
                       </a:r>
-                      <a:endParaRPr lang="en-US" sz="1500" dirty="0">
+                      <a:endParaRPr lang="en-US" sz="1400" dirty="0">
                         <a:latin typeface="Calibri" charset="0"/>
                         <a:ea typeface="Calibri" charset="0"/>
                         <a:cs typeface="Calibri" charset="0"/>
@@ -8621,7 +8895,7 @@
                         <a:buNone/>
                       </a:pPr>
                       <a:r>
-                        <a:rPr lang="en-US" sz="1500" b="1" dirty="0">
+                        <a:rPr lang="en-US" sz="1400" b="1" dirty="0">
                           <a:solidFill>
                             <a:srgbClr val="2B2B2B"/>
                           </a:solidFill>
@@ -8631,7 +8905,7 @@
                         </a:rPr>
                         <a:t>0.2793</a:t>
                       </a:r>
-                      <a:endParaRPr lang="en-US" sz="1500" dirty="0">
+                      <a:endParaRPr lang="en-US" sz="1400" dirty="0">
                         <a:latin typeface="Calibri" charset="0"/>
                         <a:ea typeface="Calibri" charset="0"/>
                         <a:cs typeface="Calibri" charset="0"/>
@@ -8689,7 +8963,7 @@
                         <a:buNone/>
                       </a:pPr>
                       <a:r>
-                        <a:rPr lang="en-US" sz="1500" b="1" dirty="0">
+                        <a:rPr lang="en-US" sz="1400" b="1" dirty="0">
                           <a:solidFill>
                             <a:srgbClr val="2B2B2B"/>
                           </a:solidFill>
@@ -8699,7 +8973,7 @@
                         </a:rPr>
                         <a:t>0.3410</a:t>
                       </a:r>
-                      <a:endParaRPr lang="en-US" sz="1500" dirty="0">
+                      <a:endParaRPr lang="en-US" sz="1400" dirty="0">
                         <a:latin typeface="Calibri" charset="0"/>
                         <a:ea typeface="Calibri" charset="0"/>
                         <a:cs typeface="Calibri" charset="0"/>
@@ -8850,7 +9124,7 @@
                 <a:ea typeface="Calibri" pitchFamily="34" charset="-122"/>
                 <a:cs typeface="Calibri" pitchFamily="34" charset="-120"/>
               </a:rPr>
-              <a:t>Gold gần sapo nên 1 câu đầu đã khớp. Oracle chứng tỏ extractive chưa hết sức — Lead-3 chưa chọn đúng 3 câu. ViT5-500: notebook Kaggle riêng, chưa chạy.</a:t>
+              <a:t>Cùng generate n=100; 100 bài đầu trùng preds.json. Gold gần sapo nên Lead-1 đã cao. ViT5 hơn Lead-1 một chút. Oracle ≈ 0,46: extractive còn cửa, Lead-3 chưa chọn đúng câu.</a:t>
             </a:r>
             <a:endParaRPr lang="en-US" sz="1500" dirty="0"/>
           </a:p>
@@ -11211,7 +11485,7 @@
                 <a:ea typeface="Calibri" pitchFamily="34" charset="-122"/>
                 <a:cs typeface="Calibri" pitchFamily="34" charset="-120"/>
               </a:rPr>
-              <a:t>Trên 100 bài test đầu Vietnews, ViT5 ROUGE-1/2/L cao hơn Lead-3 và TextRank một chút.</a:t>
+              <a:t>Trên 100 bài test đầu, ViT5 ROUGE cao hơn Lead-3 và TextRank một chút. n=500: ViT5 0,2784 &gt; Lead-1 0,2719.</a:t>
             </a:r>
             <a:endParaRPr lang="en-US" sz="1500" dirty="0"/>
           </a:p>
@@ -11367,7 +11641,7 @@
                 <a:ea typeface="Calibri" pitchFamily="34" charset="-122"/>
                 <a:cs typeface="Calibri" pitchFamily="34" charset="-120"/>
               </a:rPr>
-              <a:t>Chỉ 100 bài, không phải full test gốc paper.</a:t>
+              <a:t>Đọc tay / lệch số trên 100 bài; ROUGE 500 không thay error analysis.</a:t>
             </a:r>
             <a:endParaRPr lang="en-US" sz="1500" dirty="0"/>
           </a:p>

</xml_diff>

<commit_message>
Add locked ViT5 ROUGE on 500 articles; keep the n=100 table unchanged.
ViT5 0.2784/0.1474/0.2233 vs Lead-1 0.2719. First 100 preds match preds.json.
</commit_message>
<xml_diff>
--- a/slides/CS221-Vietnews-tom-tat.pptx
+++ b/slides/CS221-Vietnews-tom-tat.pptx
@@ -7018,7 +7018,7 @@
                 <a:ea typeface="Calibri" pitchFamily="34" charset="-122"/>
                 <a:cs typeface="Calibri" pitchFamily="34" charset="-120"/>
               </a:rPr>
-              <a:t>10c  N = 500  ·  EXTRACTIVE</a:t>
+              <a:t>10c  N = 500</a:t>
             </a:r>
             <a:endParaRPr lang="en-US" sz="1100" dirty="0"/>
           </a:p>
@@ -7119,7 +7119,7 @@
                 <a:ea typeface="Georgia" pitchFamily="34" charset="-122"/>
                 <a:cs typeface="Georgia" pitchFamily="34" charset="-120"/>
               </a:rPr>
-              <a:t>Lead-1 &gt; Lead-3. Oracle-3 ≈ 0,46 — còn câu tốt hơn 3 câu đầu.</a:t>
+              <a:t>ViT5 0,2784 &gt; Lead-1 0,2719. Oracle-3 ≈ 0,46.</a:t>
             </a:r>
             <a:endParaRPr lang="en-US" sz="2000" dirty="0"/>
           </a:p>
@@ -7153,7 +7153,7 @@
                 <a:gridCol w="1618488"/>
                 <a:gridCol w="1609344"/>
               </a:tblGrid>
-              <a:tr h="701040">
+              <a:tr h="600891">
                 <a:tc>
                   <a:txBody>
                     <a:bodyPr/>
@@ -7163,7 +7163,7 @@
                         <a:buNone/>
                       </a:pPr>
                       <a:r>
-                        <a:rPr lang="en-US" sz="1500" b="1" dirty="0">
+                        <a:rPr lang="en-US" sz="1400" b="1" dirty="0">
                           <a:solidFill>
                             <a:srgbClr val="EFE8D6"/>
                           </a:solidFill>
@@ -7173,7 +7173,7 @@
                         </a:rPr>
                         <a:t>Hệ</a:t>
                       </a:r>
-                      <a:endParaRPr lang="en-US" sz="1500" dirty="0">
+                      <a:endParaRPr lang="en-US" sz="1400" dirty="0">
                         <a:latin typeface="Calibri" charset="0"/>
                         <a:ea typeface="Calibri" charset="0"/>
                         <a:cs typeface="Calibri" charset="0"/>
@@ -7231,7 +7231,7 @@
                         <a:buNone/>
                       </a:pPr>
                       <a:r>
-                        <a:rPr lang="en-US" sz="1500" b="1" dirty="0">
+                        <a:rPr lang="en-US" sz="1400" b="1" dirty="0">
                           <a:solidFill>
                             <a:srgbClr val="EFE8D6"/>
                           </a:solidFill>
@@ -7241,7 +7241,7 @@
                         </a:rPr>
                         <a:t>ROUGE-1</a:t>
                       </a:r>
-                      <a:endParaRPr lang="en-US" sz="1500" dirty="0">
+                      <a:endParaRPr lang="en-US" sz="1400" dirty="0">
                         <a:latin typeface="Calibri" charset="0"/>
                         <a:ea typeface="Calibri" charset="0"/>
                         <a:cs typeface="Calibri" charset="0"/>
@@ -7299,7 +7299,7 @@
                         <a:buNone/>
                       </a:pPr>
                       <a:r>
-                        <a:rPr lang="en-US" sz="1500" b="1" dirty="0">
+                        <a:rPr lang="en-US" sz="1400" b="1" dirty="0">
                           <a:solidFill>
                             <a:srgbClr val="EFE8D6"/>
                           </a:solidFill>
@@ -7309,7 +7309,7 @@
                         </a:rPr>
                         <a:t>ROUGE-2</a:t>
                       </a:r>
-                      <a:endParaRPr lang="en-US" sz="1500" dirty="0">
+                      <a:endParaRPr lang="en-US" sz="1400" dirty="0">
                         <a:latin typeface="Calibri" charset="0"/>
                         <a:ea typeface="Calibri" charset="0"/>
                         <a:cs typeface="Calibri" charset="0"/>
@@ -7367,7 +7367,7 @@
                         <a:buNone/>
                       </a:pPr>
                       <a:r>
-                        <a:rPr lang="en-US" sz="1500" b="1" dirty="0">
+                        <a:rPr lang="en-US" sz="1400" b="1" dirty="0">
                           <a:solidFill>
                             <a:srgbClr val="EFE8D6"/>
                           </a:solidFill>
@@ -7377,7 +7377,7 @@
                         </a:rPr>
                         <a:t>ROUGE-L</a:t>
                       </a:r>
-                      <a:endParaRPr lang="en-US" sz="1500" dirty="0">
+                      <a:endParaRPr lang="en-US" sz="1400" dirty="0">
                         <a:latin typeface="Calibri" charset="0"/>
                         <a:ea typeface="Calibri" charset="0"/>
                         <a:cs typeface="Calibri" charset="0"/>
@@ -7427,7 +7427,7 @@
                   </a:tcPr>
                 </a:tc>
               </a:tr>
-              <a:tr h="701040">
+              <a:tr h="600891">
                 <a:tc>
                   <a:txBody>
                     <a:bodyPr/>
@@ -7437,7 +7437,7 @@
                         <a:buNone/>
                       </a:pPr>
                       <a:r>
-                        <a:rPr lang="en-US" sz="1500" dirty="0">
+                        <a:rPr lang="en-US" sz="1400" dirty="0">
                           <a:solidFill>
                             <a:srgbClr val="2B2B2B"/>
                           </a:solidFill>
@@ -7447,7 +7447,7 @@
                         </a:rPr>
                         <a:t>Lead-1</a:t>
                       </a:r>
-                      <a:endParaRPr lang="en-US" sz="1500" dirty="0">
+                      <a:endParaRPr lang="en-US" sz="1400" dirty="0">
                         <a:latin typeface="Calibri" charset="0"/>
                         <a:ea typeface="Calibri" charset="0"/>
                         <a:cs typeface="Calibri" charset="0"/>
@@ -7502,7 +7502,7 @@
                         <a:buNone/>
                       </a:pPr>
                       <a:r>
-                        <a:rPr lang="en-US" sz="1500" dirty="0">
+                        <a:rPr lang="en-US" sz="1400" dirty="0">
                           <a:solidFill>
                             <a:srgbClr val="2B2B2B"/>
                           </a:solidFill>
@@ -7512,7 +7512,7 @@
                         </a:rPr>
                         <a:t>0.2719</a:t>
                       </a:r>
-                      <a:endParaRPr lang="en-US" sz="1500" dirty="0">
+                      <a:endParaRPr lang="en-US" sz="1400" dirty="0">
                         <a:latin typeface="Calibri" charset="0"/>
                         <a:ea typeface="Calibri" charset="0"/>
                         <a:cs typeface="Calibri" charset="0"/>
@@ -7567,7 +7567,7 @@
                         <a:buNone/>
                       </a:pPr>
                       <a:r>
-                        <a:rPr lang="en-US" sz="1500" dirty="0">
+                        <a:rPr lang="en-US" sz="1400" dirty="0">
                           <a:solidFill>
                             <a:srgbClr val="2B2B2B"/>
                           </a:solidFill>
@@ -7577,7 +7577,7 @@
                         </a:rPr>
                         <a:t>0.1305</a:t>
                       </a:r>
-                      <a:endParaRPr lang="en-US" sz="1500" dirty="0">
+                      <a:endParaRPr lang="en-US" sz="1400" dirty="0">
                         <a:latin typeface="Calibri" charset="0"/>
                         <a:ea typeface="Calibri" charset="0"/>
                         <a:cs typeface="Calibri" charset="0"/>
@@ -7632,7 +7632,7 @@
                         <a:buNone/>
                       </a:pPr>
                       <a:r>
-                        <a:rPr lang="en-US" sz="1500" dirty="0">
+                        <a:rPr lang="en-US" sz="1400" dirty="0">
                           <a:solidFill>
                             <a:srgbClr val="2B2B2B"/>
                           </a:solidFill>
@@ -7642,7 +7642,7 @@
                         </a:rPr>
                         <a:t>0.2092</a:t>
                       </a:r>
-                      <a:endParaRPr lang="en-US" sz="1500" dirty="0">
+                      <a:endParaRPr lang="en-US" sz="1400" dirty="0">
                         <a:latin typeface="Calibri" charset="0"/>
                         <a:ea typeface="Calibri" charset="0"/>
                         <a:cs typeface="Calibri" charset="0"/>
@@ -7689,7 +7689,7 @@
                   </a:tcPr>
                 </a:tc>
               </a:tr>
-              <a:tr h="701040">
+              <a:tr h="600891">
                 <a:tc>
                   <a:txBody>
                     <a:bodyPr/>
@@ -7699,7 +7699,7 @@
                         <a:buNone/>
                       </a:pPr>
                       <a:r>
-                        <a:rPr lang="en-US" sz="1500" dirty="0">
+                        <a:rPr lang="en-US" sz="1400" dirty="0">
                           <a:solidFill>
                             <a:srgbClr val="2B2B2B"/>
                           </a:solidFill>
@@ -7709,7 +7709,7 @@
                         </a:rPr>
                         <a:t>Lead-3</a:t>
                       </a:r>
-                      <a:endParaRPr lang="en-US" sz="1500" dirty="0">
+                      <a:endParaRPr lang="en-US" sz="1400" dirty="0">
                         <a:latin typeface="Calibri" charset="0"/>
                         <a:ea typeface="Calibri" charset="0"/>
                         <a:cs typeface="Calibri" charset="0"/>
@@ -7764,7 +7764,7 @@
                         <a:buNone/>
                       </a:pPr>
                       <a:r>
-                        <a:rPr lang="en-US" sz="1500" dirty="0">
+                        <a:rPr lang="en-US" sz="1400" dirty="0">
                           <a:solidFill>
                             <a:srgbClr val="2B2B2B"/>
                           </a:solidFill>
@@ -7774,7 +7774,7 @@
                         </a:rPr>
                         <a:t>0.2569</a:t>
                       </a:r>
-                      <a:endParaRPr lang="en-US" sz="1500" dirty="0">
+                      <a:endParaRPr lang="en-US" sz="1400" dirty="0">
                         <a:latin typeface="Calibri" charset="0"/>
                         <a:ea typeface="Calibri" charset="0"/>
                         <a:cs typeface="Calibri" charset="0"/>
@@ -7829,7 +7829,7 @@
                         <a:buNone/>
                       </a:pPr>
                       <a:r>
-                        <a:rPr lang="en-US" sz="1500" dirty="0">
+                        <a:rPr lang="en-US" sz="1400" dirty="0">
                           <a:solidFill>
                             <a:srgbClr val="2B2B2B"/>
                           </a:solidFill>
@@ -7839,7 +7839,7 @@
                         </a:rPr>
                         <a:t>0.1294</a:t>
                       </a:r>
-                      <a:endParaRPr lang="en-US" sz="1500" dirty="0">
+                      <a:endParaRPr lang="en-US" sz="1400" dirty="0">
                         <a:latin typeface="Calibri" charset="0"/>
                         <a:ea typeface="Calibri" charset="0"/>
                         <a:cs typeface="Calibri" charset="0"/>
@@ -7894,7 +7894,7 @@
                         <a:buNone/>
                       </a:pPr>
                       <a:r>
-                        <a:rPr lang="en-US" sz="1500" dirty="0">
+                        <a:rPr lang="en-US" sz="1400" dirty="0">
                           <a:solidFill>
                             <a:srgbClr val="2B2B2B"/>
                           </a:solidFill>
@@ -7904,7 +7904,7 @@
                         </a:rPr>
                         <a:t>0.1856</a:t>
                       </a:r>
-                      <a:endParaRPr lang="en-US" sz="1500" dirty="0">
+                      <a:endParaRPr lang="en-US" sz="1400" dirty="0">
                         <a:latin typeface="Calibri" charset="0"/>
                         <a:ea typeface="Calibri" charset="0"/>
                         <a:cs typeface="Calibri" charset="0"/>
@@ -7951,7 +7951,7 @@
                   </a:tcPr>
                 </a:tc>
               </a:tr>
-              <a:tr h="701040">
+              <a:tr h="600891">
                 <a:tc>
                   <a:txBody>
                     <a:bodyPr/>
@@ -7961,7 +7961,7 @@
                         <a:buNone/>
                       </a:pPr>
                       <a:r>
-                        <a:rPr lang="en-US" sz="1500" dirty="0">
+                        <a:rPr lang="en-US" sz="1400" dirty="0">
                           <a:solidFill>
                             <a:srgbClr val="2B2B2B"/>
                           </a:solidFill>
@@ -7971,7 +7971,7 @@
                         </a:rPr>
                         <a:t>Lead-5</a:t>
                       </a:r>
-                      <a:endParaRPr lang="en-US" sz="1500" dirty="0">
+                      <a:endParaRPr lang="en-US" sz="1400" dirty="0">
                         <a:latin typeface="Calibri" charset="0"/>
                         <a:ea typeface="Calibri" charset="0"/>
                         <a:cs typeface="Calibri" charset="0"/>
@@ -8026,7 +8026,7 @@
                         <a:buNone/>
                       </a:pPr>
                       <a:r>
-                        <a:rPr lang="en-US" sz="1500" dirty="0">
+                        <a:rPr lang="en-US" sz="1400" dirty="0">
                           <a:solidFill>
                             <a:srgbClr val="2B2B2B"/>
                           </a:solidFill>
@@ -8036,7 +8036,7 @@
                         </a:rPr>
                         <a:t>0.2256</a:t>
                       </a:r>
-                      <a:endParaRPr lang="en-US" sz="1500" dirty="0">
+                      <a:endParaRPr lang="en-US" sz="1400" dirty="0">
                         <a:latin typeface="Calibri" charset="0"/>
                         <a:ea typeface="Calibri" charset="0"/>
                         <a:cs typeface="Calibri" charset="0"/>
@@ -8091,7 +8091,7 @@
                         <a:buNone/>
                       </a:pPr>
                       <a:r>
-                        <a:rPr lang="en-US" sz="1500" dirty="0">
+                        <a:rPr lang="en-US" sz="1400" dirty="0">
                           <a:solidFill>
                             <a:srgbClr val="2B2B2B"/>
                           </a:solidFill>
@@ -8101,7 +8101,7 @@
                         </a:rPr>
                         <a:t>0.1199</a:t>
                       </a:r>
-                      <a:endParaRPr lang="en-US" sz="1500" dirty="0">
+                      <a:endParaRPr lang="en-US" sz="1400" dirty="0">
                         <a:latin typeface="Calibri" charset="0"/>
                         <a:ea typeface="Calibri" charset="0"/>
                         <a:cs typeface="Calibri" charset="0"/>
@@ -8156,7 +8156,7 @@
                         <a:buNone/>
                       </a:pPr>
                       <a:r>
-                        <a:rPr lang="en-US" sz="1500" dirty="0">
+                        <a:rPr lang="en-US" sz="1400" dirty="0">
                           <a:solidFill>
                             <a:srgbClr val="2B2B2B"/>
                           </a:solidFill>
@@ -8166,7 +8166,7 @@
                         </a:rPr>
                         <a:t>0.1624</a:t>
                       </a:r>
-                      <a:endParaRPr lang="en-US" sz="1500" dirty="0">
+                      <a:endParaRPr lang="en-US" sz="1400" dirty="0">
                         <a:latin typeface="Calibri" charset="0"/>
                         <a:ea typeface="Calibri" charset="0"/>
                         <a:cs typeface="Calibri" charset="0"/>
@@ -8213,7 +8213,7 @@
                   </a:tcPr>
                 </a:tc>
               </a:tr>
-              <a:tr h="701040">
+              <a:tr h="600891">
                 <a:tc>
                   <a:txBody>
                     <a:bodyPr/>
@@ -8223,7 +8223,7 @@
                         <a:buNone/>
                       </a:pPr>
                       <a:r>
-                        <a:rPr lang="en-US" sz="1500" dirty="0">
+                        <a:rPr lang="en-US" sz="1400" dirty="0">
                           <a:solidFill>
                             <a:srgbClr val="2B2B2B"/>
                           </a:solidFill>
@@ -8233,7 +8233,7 @@
                         </a:rPr>
                         <a:t>TextRank-3</a:t>
                       </a:r>
-                      <a:endParaRPr lang="en-US" sz="1500" dirty="0">
+                      <a:endParaRPr lang="en-US" sz="1400" dirty="0">
                         <a:latin typeface="Calibri" charset="0"/>
                         <a:ea typeface="Calibri" charset="0"/>
                         <a:cs typeface="Calibri" charset="0"/>
@@ -8288,7 +8288,7 @@
                         <a:buNone/>
                       </a:pPr>
                       <a:r>
-                        <a:rPr lang="en-US" sz="1500" dirty="0">
+                        <a:rPr lang="en-US" sz="1400" dirty="0">
                           <a:solidFill>
                             <a:srgbClr val="2B2B2B"/>
                           </a:solidFill>
@@ -8298,7 +8298,7 @@
                         </a:rPr>
                         <a:t>0.2499</a:t>
                       </a:r>
-                      <a:endParaRPr lang="en-US" sz="1500" dirty="0">
+                      <a:endParaRPr lang="en-US" sz="1400" dirty="0">
                         <a:latin typeface="Calibri" charset="0"/>
                         <a:ea typeface="Calibri" charset="0"/>
                         <a:cs typeface="Calibri" charset="0"/>
@@ -8353,7 +8353,7 @@
                         <a:buNone/>
                       </a:pPr>
                       <a:r>
-                        <a:rPr lang="en-US" sz="1500" dirty="0">
+                        <a:rPr lang="en-US" sz="1400" dirty="0">
                           <a:solidFill>
                             <a:srgbClr val="2B2B2B"/>
                           </a:solidFill>
@@ -8363,7 +8363,7 @@
                         </a:rPr>
                         <a:t>0.1198</a:t>
                       </a:r>
-                      <a:endParaRPr lang="en-US" sz="1500" dirty="0">
+                      <a:endParaRPr lang="en-US" sz="1400" dirty="0">
                         <a:latin typeface="Calibri" charset="0"/>
                         <a:ea typeface="Calibri" charset="0"/>
                         <a:cs typeface="Calibri" charset="0"/>
@@ -8418,7 +8418,7 @@
                         <a:buNone/>
                       </a:pPr>
                       <a:r>
-                        <a:rPr lang="en-US" sz="1500" dirty="0">
+                        <a:rPr lang="en-US" sz="1400" dirty="0">
                           <a:solidFill>
                             <a:srgbClr val="2B2B2B"/>
                           </a:solidFill>
@@ -8428,7 +8428,7 @@
                         </a:rPr>
                         <a:t>0.1815</a:t>
                       </a:r>
-                      <a:endParaRPr lang="en-US" sz="1500" dirty="0">
+                      <a:endParaRPr lang="en-US" sz="1400" dirty="0">
                         <a:latin typeface="Calibri" charset="0"/>
                         <a:ea typeface="Calibri" charset="0"/>
                         <a:cs typeface="Calibri" charset="0"/>
@@ -8475,7 +8475,7 @@
                   </a:tcPr>
                 </a:tc>
               </a:tr>
-              <a:tr h="701040">
+              <a:tr h="600891">
                 <a:tc>
                   <a:txBody>
                     <a:bodyPr/>
@@ -8485,7 +8485,281 @@
                         <a:buNone/>
                       </a:pPr>
                       <a:r>
-                        <a:rPr lang="en-US" sz="1500" b="1" dirty="0">
+                        <a:rPr lang="en-US" sz="1400" b="1" dirty="0">
+                          <a:solidFill>
+                            <a:srgbClr val="2B2B2B"/>
+                          </a:solidFill>
+                          <a:latin typeface="Calibri" pitchFamily="34" charset="0"/>
+                          <a:ea typeface="Calibri" pitchFamily="34" charset="-122"/>
+                          <a:cs typeface="Calibri" pitchFamily="34" charset="-120"/>
+                        </a:rPr>
+                        <a:t>ViT5</a:t>
+                      </a:r>
+                      <a:endParaRPr lang="en-US" sz="1400" dirty="0">
+                        <a:latin typeface="Calibri" charset="0"/>
+                        <a:ea typeface="Calibri" charset="0"/>
+                        <a:cs typeface="Calibri" charset="0"/>
+                      </a:endParaRPr>
+                    </a:p>
+                  </a:txBody>
+                  <a:tcPr marL="91440" marR="91440" marT="45720" marB="45720" anchor="ctr">
+                    <a:lnL w="6350" cap="flat" cmpd="sng" algn="ctr">
+                      <a:solidFill>
+                        <a:srgbClr val="C8C0AE"/>
+                      </a:solidFill>
+                      <a:prstDash val="solid"/>
+                      <a:round/>
+                      <a:headEnd type="none" w="med" len="med"/>
+                      <a:tailEnd type="none" w="med" len="med"/>
+                    </a:lnL>
+                    <a:lnR w="6350" cap="flat" cmpd="sng" algn="ctr">
+                      <a:solidFill>
+                        <a:srgbClr val="C8C0AE"/>
+                      </a:solidFill>
+                      <a:prstDash val="solid"/>
+                      <a:round/>
+                      <a:headEnd type="none" w="med" len="med"/>
+                      <a:tailEnd type="none" w="med" len="med"/>
+                    </a:lnR>
+                    <a:lnT w="6350" cap="flat" cmpd="sng" algn="ctr">
+                      <a:solidFill>
+                        <a:srgbClr val="C8C0AE"/>
+                      </a:solidFill>
+                      <a:prstDash val="solid"/>
+                      <a:round/>
+                      <a:headEnd type="none" w="med" len="med"/>
+                      <a:tailEnd type="none" w="med" len="med"/>
+                    </a:lnT>
+                    <a:lnB w="6350" cap="flat" cmpd="sng" algn="ctr">
+                      <a:solidFill>
+                        <a:srgbClr val="C8C0AE"/>
+                      </a:solidFill>
+                      <a:prstDash val="solid"/>
+                      <a:round/>
+                      <a:headEnd type="none" w="med" len="med"/>
+                      <a:tailEnd type="none" w="med" len="med"/>
+                    </a:lnB>
+                    <a:solidFill>
+                      <a:srgbClr val="F7F3E8"/>
+                    </a:solidFill>
+                  </a:tcPr>
+                </a:tc>
+                <a:tc>
+                  <a:txBody>
+                    <a:bodyPr/>
+                    <a:lstStyle/>
+                    <a:p>
+                      <a:pPr algn="ctr" indent="0" marL="0">
+                        <a:buNone/>
+                      </a:pPr>
+                      <a:r>
+                        <a:rPr lang="en-US" sz="1400" b="1" dirty="0">
+                          <a:solidFill>
+                            <a:srgbClr val="2B2B2B"/>
+                          </a:solidFill>
+                          <a:latin typeface="Calibri" pitchFamily="34" charset="0"/>
+                          <a:ea typeface="Calibri" pitchFamily="34" charset="-122"/>
+                          <a:cs typeface="Calibri" pitchFamily="34" charset="-120"/>
+                        </a:rPr>
+                        <a:t>0.2784</a:t>
+                      </a:r>
+                      <a:endParaRPr lang="en-US" sz="1400" dirty="0">
+                        <a:latin typeface="Calibri" charset="0"/>
+                        <a:ea typeface="Calibri" charset="0"/>
+                        <a:cs typeface="Calibri" charset="0"/>
+                      </a:endParaRPr>
+                    </a:p>
+                  </a:txBody>
+                  <a:tcPr marL="91440" marR="91440" marT="45720" marB="45720" anchor="ctr">
+                    <a:lnL w="6350" cap="flat" cmpd="sng" algn="ctr">
+                      <a:solidFill>
+                        <a:srgbClr val="C8C0AE"/>
+                      </a:solidFill>
+                      <a:prstDash val="solid"/>
+                      <a:round/>
+                      <a:headEnd type="none" w="med" len="med"/>
+                      <a:tailEnd type="none" w="med" len="med"/>
+                    </a:lnL>
+                    <a:lnR w="6350" cap="flat" cmpd="sng" algn="ctr">
+                      <a:solidFill>
+                        <a:srgbClr val="C8C0AE"/>
+                      </a:solidFill>
+                      <a:prstDash val="solid"/>
+                      <a:round/>
+                      <a:headEnd type="none" w="med" len="med"/>
+                      <a:tailEnd type="none" w="med" len="med"/>
+                    </a:lnR>
+                    <a:lnT w="6350" cap="flat" cmpd="sng" algn="ctr">
+                      <a:solidFill>
+                        <a:srgbClr val="C8C0AE"/>
+                      </a:solidFill>
+                      <a:prstDash val="solid"/>
+                      <a:round/>
+                      <a:headEnd type="none" w="med" len="med"/>
+                      <a:tailEnd type="none" w="med" len="med"/>
+                    </a:lnT>
+                    <a:lnB w="6350" cap="flat" cmpd="sng" algn="ctr">
+                      <a:solidFill>
+                        <a:srgbClr val="C8C0AE"/>
+                      </a:solidFill>
+                      <a:prstDash val="solid"/>
+                      <a:round/>
+                      <a:headEnd type="none" w="med" len="med"/>
+                      <a:tailEnd type="none" w="med" len="med"/>
+                    </a:lnB>
+                    <a:solidFill>
+                      <a:srgbClr val="F7F3E8"/>
+                    </a:solidFill>
+                  </a:tcPr>
+                </a:tc>
+                <a:tc>
+                  <a:txBody>
+                    <a:bodyPr/>
+                    <a:lstStyle/>
+                    <a:p>
+                      <a:pPr algn="ctr" indent="0" marL="0">
+                        <a:buNone/>
+                      </a:pPr>
+                      <a:r>
+                        <a:rPr lang="en-US" sz="1400" b="1" dirty="0">
+                          <a:solidFill>
+                            <a:srgbClr val="2B2B2B"/>
+                          </a:solidFill>
+                          <a:latin typeface="Calibri" pitchFamily="34" charset="0"/>
+                          <a:ea typeface="Calibri" pitchFamily="34" charset="-122"/>
+                          <a:cs typeface="Calibri" pitchFamily="34" charset="-120"/>
+                        </a:rPr>
+                        <a:t>0.1474</a:t>
+                      </a:r>
+                      <a:endParaRPr lang="en-US" sz="1400" dirty="0">
+                        <a:latin typeface="Calibri" charset="0"/>
+                        <a:ea typeface="Calibri" charset="0"/>
+                        <a:cs typeface="Calibri" charset="0"/>
+                      </a:endParaRPr>
+                    </a:p>
+                  </a:txBody>
+                  <a:tcPr marL="91440" marR="91440" marT="45720" marB="45720" anchor="ctr">
+                    <a:lnL w="6350" cap="flat" cmpd="sng" algn="ctr">
+                      <a:solidFill>
+                        <a:srgbClr val="C8C0AE"/>
+                      </a:solidFill>
+                      <a:prstDash val="solid"/>
+                      <a:round/>
+                      <a:headEnd type="none" w="med" len="med"/>
+                      <a:tailEnd type="none" w="med" len="med"/>
+                    </a:lnL>
+                    <a:lnR w="6350" cap="flat" cmpd="sng" algn="ctr">
+                      <a:solidFill>
+                        <a:srgbClr val="C8C0AE"/>
+                      </a:solidFill>
+                      <a:prstDash val="solid"/>
+                      <a:round/>
+                      <a:headEnd type="none" w="med" len="med"/>
+                      <a:tailEnd type="none" w="med" len="med"/>
+                    </a:lnR>
+                    <a:lnT w="6350" cap="flat" cmpd="sng" algn="ctr">
+                      <a:solidFill>
+                        <a:srgbClr val="C8C0AE"/>
+                      </a:solidFill>
+                      <a:prstDash val="solid"/>
+                      <a:round/>
+                      <a:headEnd type="none" w="med" len="med"/>
+                      <a:tailEnd type="none" w="med" len="med"/>
+                    </a:lnT>
+                    <a:lnB w="6350" cap="flat" cmpd="sng" algn="ctr">
+                      <a:solidFill>
+                        <a:srgbClr val="C8C0AE"/>
+                      </a:solidFill>
+                      <a:prstDash val="solid"/>
+                      <a:round/>
+                      <a:headEnd type="none" w="med" len="med"/>
+                      <a:tailEnd type="none" w="med" len="med"/>
+                    </a:lnB>
+                    <a:solidFill>
+                      <a:srgbClr val="F7F3E8"/>
+                    </a:solidFill>
+                  </a:tcPr>
+                </a:tc>
+                <a:tc>
+                  <a:txBody>
+                    <a:bodyPr/>
+                    <a:lstStyle/>
+                    <a:p>
+                      <a:pPr algn="ctr" indent="0" marL="0">
+                        <a:buNone/>
+                      </a:pPr>
+                      <a:r>
+                        <a:rPr lang="en-US" sz="1400" b="1" dirty="0">
+                          <a:solidFill>
+                            <a:srgbClr val="2B2B2B"/>
+                          </a:solidFill>
+                          <a:latin typeface="Calibri" pitchFamily="34" charset="0"/>
+                          <a:ea typeface="Calibri" pitchFamily="34" charset="-122"/>
+                          <a:cs typeface="Calibri" pitchFamily="34" charset="-120"/>
+                        </a:rPr>
+                        <a:t>0.2233</a:t>
+                      </a:r>
+                      <a:endParaRPr lang="en-US" sz="1400" dirty="0">
+                        <a:latin typeface="Calibri" charset="0"/>
+                        <a:ea typeface="Calibri" charset="0"/>
+                        <a:cs typeface="Calibri" charset="0"/>
+                      </a:endParaRPr>
+                    </a:p>
+                  </a:txBody>
+                  <a:tcPr marL="91440" marR="91440" marT="45720" marB="45720" anchor="ctr">
+                    <a:lnL w="6350" cap="flat" cmpd="sng" algn="ctr">
+                      <a:solidFill>
+                        <a:srgbClr val="C8C0AE"/>
+                      </a:solidFill>
+                      <a:prstDash val="solid"/>
+                      <a:round/>
+                      <a:headEnd type="none" w="med" len="med"/>
+                      <a:tailEnd type="none" w="med" len="med"/>
+                    </a:lnL>
+                    <a:lnR w="6350" cap="flat" cmpd="sng" algn="ctr">
+                      <a:solidFill>
+                        <a:srgbClr val="C8C0AE"/>
+                      </a:solidFill>
+                      <a:prstDash val="solid"/>
+                      <a:round/>
+                      <a:headEnd type="none" w="med" len="med"/>
+                      <a:tailEnd type="none" w="med" len="med"/>
+                    </a:lnR>
+                    <a:lnT w="6350" cap="flat" cmpd="sng" algn="ctr">
+                      <a:solidFill>
+                        <a:srgbClr val="C8C0AE"/>
+                      </a:solidFill>
+                      <a:prstDash val="solid"/>
+                      <a:round/>
+                      <a:headEnd type="none" w="med" len="med"/>
+                      <a:tailEnd type="none" w="med" len="med"/>
+                    </a:lnT>
+                    <a:lnB w="6350" cap="flat" cmpd="sng" algn="ctr">
+                      <a:solidFill>
+                        <a:srgbClr val="C8C0AE"/>
+                      </a:solidFill>
+                      <a:prstDash val="solid"/>
+                      <a:round/>
+                      <a:headEnd type="none" w="med" len="med"/>
+                      <a:tailEnd type="none" w="med" len="med"/>
+                    </a:lnB>
+                    <a:solidFill>
+                      <a:srgbClr val="F7F3E8"/>
+                    </a:solidFill>
+                  </a:tcPr>
+                </a:tc>
+              </a:tr>
+              <a:tr h="600891">
+                <a:tc>
+                  <a:txBody>
+                    <a:bodyPr/>
+                    <a:lstStyle/>
+                    <a:p>
+                      <a:pPr algn="ctr" indent="0" marL="0">
+                        <a:buNone/>
+                      </a:pPr>
+                      <a:r>
+                        <a:rPr lang="en-US" sz="1400" b="1" dirty="0">
                           <a:solidFill>
                             <a:srgbClr val="2B2B2B"/>
                           </a:solidFill>
@@ -8495,7 +8769,7 @@
                         </a:rPr>
                         <a:t>Oracle-3</a:t>
                       </a:r>
-                      <a:endParaRPr lang="en-US" sz="1500" dirty="0">
+                      <a:endParaRPr lang="en-US" sz="1400" dirty="0">
                         <a:latin typeface="Calibri" charset="0"/>
                         <a:ea typeface="Calibri" charset="0"/>
                         <a:cs typeface="Calibri" charset="0"/>
@@ -8553,7 +8827,7 @@
                         <a:buNone/>
                       </a:pPr>
                       <a:r>
-                        <a:rPr lang="en-US" sz="1500" b="1" dirty="0">
+                        <a:rPr lang="en-US" sz="1400" b="1" dirty="0">
                           <a:solidFill>
                             <a:srgbClr val="2B2B2B"/>
                           </a:solidFill>
@@ -8563,7 +8837,7 @@
                         </a:rPr>
                         <a:t>0.4646</a:t>
                       </a:r>
-                      <a:endParaRPr lang="en-US" sz="1500" dirty="0">
+                      <a:endParaRPr lang="en-US" sz="1400" dirty="0">
                         <a:latin typeface="Calibri" charset="0"/>
                         <a:ea typeface="Calibri" charset="0"/>
                         <a:cs typeface="Calibri" charset="0"/>
@@ -8621,7 +8895,7 @@
                         <a:buNone/>
                       </a:pPr>
                       <a:r>
-                        <a:rPr lang="en-US" sz="1500" b="1" dirty="0">
+                        <a:rPr lang="en-US" sz="1400" b="1" dirty="0">
                           <a:solidFill>
                             <a:srgbClr val="2B2B2B"/>
                           </a:solidFill>
@@ -8631,7 +8905,7 @@
                         </a:rPr>
                         <a:t>0.2793</a:t>
                       </a:r>
-                      <a:endParaRPr lang="en-US" sz="1500" dirty="0">
+                      <a:endParaRPr lang="en-US" sz="1400" dirty="0">
                         <a:latin typeface="Calibri" charset="0"/>
                         <a:ea typeface="Calibri" charset="0"/>
                         <a:cs typeface="Calibri" charset="0"/>
@@ -8689,7 +8963,7 @@
                         <a:buNone/>
                       </a:pPr>
                       <a:r>
-                        <a:rPr lang="en-US" sz="1500" b="1" dirty="0">
+                        <a:rPr lang="en-US" sz="1400" b="1" dirty="0">
                           <a:solidFill>
                             <a:srgbClr val="2B2B2B"/>
                           </a:solidFill>
@@ -8699,7 +8973,7 @@
                         </a:rPr>
                         <a:t>0.3410</a:t>
                       </a:r>
-                      <a:endParaRPr lang="en-US" sz="1500" dirty="0">
+                      <a:endParaRPr lang="en-US" sz="1400" dirty="0">
                         <a:latin typeface="Calibri" charset="0"/>
                         <a:ea typeface="Calibri" charset="0"/>
                         <a:cs typeface="Calibri" charset="0"/>
@@ -8850,7 +9124,7 @@
                 <a:ea typeface="Calibri" pitchFamily="34" charset="-122"/>
                 <a:cs typeface="Calibri" pitchFamily="34" charset="-120"/>
               </a:rPr>
-              <a:t>Gold gần sapo nên 1 câu đầu đã khớp. Oracle chứng tỏ extractive chưa hết sức — Lead-3 chưa chọn đúng 3 câu. ViT5-500: notebook Kaggle riêng, chưa chạy.</a:t>
+              <a:t>Cùng generate n=100; 100 bài đầu trùng preds.json. Gold gần sapo nên Lead-1 đã cao. ViT5 hơn Lead-1 một chút. Oracle ≈ 0,46: extractive còn cửa, Lead-3 chưa chọn đúng câu.</a:t>
             </a:r>
             <a:endParaRPr lang="en-US" sz="1500" dirty="0"/>
           </a:p>
@@ -11211,7 +11485,7 @@
                 <a:ea typeface="Calibri" pitchFamily="34" charset="-122"/>
                 <a:cs typeface="Calibri" pitchFamily="34" charset="-120"/>
               </a:rPr>
-              <a:t>Trên 100 bài test đầu Vietnews, ViT5 ROUGE-1/2/L cao hơn Lead-3 và TextRank một chút.</a:t>
+              <a:t>Trên 100 bài test đầu, ViT5 ROUGE cao hơn Lead-3 và TextRank một chút. n=500: ViT5 0,2784 &gt; Lead-1 0,2719.</a:t>
             </a:r>
             <a:endParaRPr lang="en-US" sz="1500" dirty="0"/>
           </a:p>
@@ -11367,7 +11641,7 @@
                 <a:ea typeface="Calibri" pitchFamily="34" charset="-122"/>
                 <a:cs typeface="Calibri" pitchFamily="34" charset="-120"/>
               </a:rPr>
-              <a:t>Chỉ 100 bài, không phải full test gốc paper.</a:t>
+              <a:t>Đọc tay / lệch số trên 100 bài; ROUGE 500 không thay error analysis.</a:t>
             </a:r>
             <a:endParaRPr lang="en-US" sz="1500" dirty="0"/>
           </a:p>

</xml_diff>